<commit_message>
feat: prepare reviewed submission materials and portable Android demo
</commit_message>
<xml_diff>
--- a/docs/user-guide/Rescue-Reports-User-Guide.pptx
+++ b/docs/user-guide/Rescue-Reports-User-Guide.pptx
@@ -513,7 +513,7 @@
           <a:p>
             <a:r>
               <a:rPr lang="en-US" dirty="0"/>
-              <a:t>The guide uses real Flutter Chrome captures from isolated local emulators with fictional accounts. Debug ribbons and emulator warnings are intentional evidence. This is not a physical-device or signed-release certification. A report does not guarantee immediate rescue.</a:t>
+              <a:t>The guide uses current Flutter Chrome captures and one identified widget notification fixture, with fictional accounts. Debug ribbons are retained. Some Chrome captures hide only the SDK warning to show the navigation dock; product source does not hide it. This is not a physical-device or signed-release certification. A report does not guarantee immediate rescue.</a:t>
             </a:r>
             <a:endParaRPr lang="en-US" dirty="0"/>
           </a:p>
@@ -953,7 +953,7 @@
           <a:p>
             <a:r>
               <a:rPr lang="en-US" dirty="0"/>
-              <a:t>Walk through the real welcome actions. It uses a conceptual route illustration, not live incident counts. Required account fields show asterisks. Do not show real passwords in a presentation.</a:t>
+              <a:t>Walk through the actual welcome actions. Its service labels describe the workflow, not live incidents. Required account fields show asterisks. Do not show real passwords in a presentation.</a:t>
             </a:r>
             <a:endParaRPr lang="en-US" dirty="0"/>
           </a:p>
@@ -1217,7 +1217,7 @@
           <a:p>
             <a:r>
               <a:rPr lang="en-US" dirty="0"/>
-              <a:t>This desktop capture shows the shared notification layout bounded to a reading column and an honest push-not-connected notice. This local environment does not certify push delivery.</a:t>
+              <a:t>This is the current native widget-rendered notification fixture, not physical-device evidence or proof of push delivery. The in-app feed and unread treatment are real components.</a:t>
             </a:r>
             <a:endParaRPr lang="en-US" dirty="0"/>
           </a:p>
@@ -1393,7 +1393,7 @@
           <a:p>
             <a:r>
               <a:rPr lang="en-US" dirty="0"/>
-              <a:t>People rescued and Status are marked required. A local emulator save in this pass stored an update and the live history showed it. The screenshot is before submission. Avoid a new key when the outcome is uncertain.</a:t>
+              <a:t>People rescued and Status are marked required. The running-app record and retry tests cover local saves and history. The submission rehearsal is recorded separately. The screenshot is before submission. Avoid a new key when the outcome is uncertain.</a:t>
             </a:r>
             <a:endParaRPr lang="en-US" dirty="0"/>
           </a:p>
@@ -1481,7 +1481,7 @@
           <a:p>
             <a:r>
               <a:rPr lang="en-US" dirty="0"/>
-              <a:t>This image is responder report detail with progress history, not the resident My Reports list. A local test operation assisted two fictional people; this is fixture data. An offline page cannot discover remote revocation instantly.</a:t>
+              <a:t>This image is responder report detail with progress history, not the resident My Reports list. The screenshot shows the history empty state; the bounded populated/paging behavior is covered by tests and the submission rehearsal. No real rescue count is claimed. An offline page cannot discover remote revocation instantly.</a:t>
             </a:r>
             <a:endParaRPr lang="en-US" dirty="0"/>
           </a:p>
@@ -7378,7 +7378,7 @@
       </p:sp>
       <p:pic>
         <p:nvPicPr>
-          <p:cNvPr id="14" name="Image 0" descr="/private/tmp/rescue-release-integration-2026-10-18/docs/user-guide/images/notifications-1440.png">    </p:cNvPr>
+          <p:cNvPr id="14" name="Image 0" descr="/private/tmp/rescue-release-integration-2026-10-18/docs/user-guide/images/notifications-390.png">    </p:cNvPr>
           <p:cNvPicPr>
             <a:picLocks noChangeAspect="1"/>
           </p:cNvPicPr>
@@ -7392,8 +7392,8 @@
         </p:blipFill>
         <p:spPr>
           <a:xfrm>
-            <a:off x="7543800" y="2743200"/>
-            <a:ext cx="3977640" cy="2761488"/>
+            <a:off x="8503920" y="1463040"/>
+            <a:ext cx="2148840" cy="4645152"/>
           </a:xfrm>
           <a:prstGeom prst="rect">
             <a:avLst/>
@@ -7543,7 +7543,7 @@
                 <a:ea typeface="Arial" pitchFamily="34" charset="-122"/>
                 <a:cs typeface="Arial" pitchFamily="34" charset="-120"/>
               </a:rPr>
-              <a:t>Review and acknowledge assignments</a:t>
+              <a:t>Review your assignments</a:t>
             </a:r>
             <a:endParaRPr lang="en-US" sz="3600" dirty="0"/>
           </a:p>

</xml_diff>

<commit_message>
docs(user-guide): update deck to the current role model (25 October)
Residents use the phone app only; rescuers use the phone app and web;
administrators use the website only; dispatcher and DMO are retired.
Regenerated the PPTX and PDF and checked the changed pages.

Co-Authored-By: Claude Haiku 5.5 <noreply@anthropic.com>
</commit_message>
<xml_diff>
--- a/docs/user-guide/Rescue-Reports-User-Guide.pptx
+++ b/docs/user-guide/Rescue-Reports-User-Guide.pptx
@@ -601,7 +601,7 @@
           <a:p>
             <a:r>
               <a:rPr lang="en-US" dirty="0"/>
-              <a:t>Use current deployment addresses from HANDOFF. Demonstrate real permitted actions only in isolated test data. DMO has no operational mutation controls. Admin has a real /admin screen. Current routes are documented in outline.md and web/src/App.tsx.</a:t>
+              <a:t>Current routes are in docs/documentation/how-it-works.md and web/src/App.tsx. Demonstrate only permitted actions, in isolated test data. Dispatcher and DMO accounts have no operational screens.</a:t>
             </a:r>
             <a:endParaRPr lang="en-US" dirty="0"/>
           </a:p>
@@ -2021,7 +2021,7 @@
                 <a:ea typeface="Arial" pitchFamily="34" charset="-122"/>
                 <a:cs typeface="Arial" pitchFamily="34" charset="-120"/>
               </a:rPr>
-              <a:t>User guide · web and mobile · 20 October 2026</a:t>
+              <a:t>User guide · web and mobile · 25 October 2026</a:t>
             </a:r>
             <a:endParaRPr lang="en-US" sz="1600" dirty="0"/>
           </a:p>
@@ -2112,7 +2112,7 @@
       </p:sp>
       <p:pic>
         <p:nvPicPr>
-          <p:cNvPr id="8" name="Image 0" descr="/private/tmp/rescue-release-integration-2026-10-18/docs/user-guide/images/welcome-390-r2.png">    </p:cNvPr>
+          <p:cNvPr id="8" name="Image 0" descr="/Users/rien/Documents/FINAL_PROJECT-rescuer-web/docs/user-guide/images/welcome-390-r2.png">    </p:cNvPr>
           <p:cNvPicPr>
             <a:picLocks noChangeAspect="1"/>
           </p:cNvPicPr>
@@ -2277,7 +2277,7 @@
                 <a:ea typeface="Arial" pitchFamily="34" charset="-122"/>
                 <a:cs typeface="Arial" pitchFamily="34" charset="-120"/>
               </a:rPr>
-              <a:t>Coordinate from the web</a:t>
+              <a:t>Work from the website</a:t>
             </a:r>
             <a:endParaRPr lang="en-US" sz="3600" dirty="0"/>
           </a:p>
@@ -2316,7 +2316,7 @@
                 <a:ea typeface="Arial" pitchFamily="34" charset="-122"/>
                 <a:cs typeface="Arial" pitchFamily="34" charset="-120"/>
               </a:rPr>
-              <a:t>Staff workspaces remain complete web routes.</a:t>
+              <a:t>Administrators and rescuers have web workspaces. Residents do not.</a:t>
             </a:r>
             <a:endParaRPr lang="en-US" sz="1600" dirty="0"/>
           </a:p>
@@ -2380,7 +2380,7 @@
                 <a:ea typeface="Arial" pitchFamily="34" charset="-122"/>
                 <a:cs typeface="Arial" pitchFamily="34" charset="-120"/>
               </a:rPr>
-              <a:t>Dispatcher</a:t>
+              <a:t>Administrator</a:t>
             </a:r>
             <a:endParaRPr lang="en-US" sz="2500" dirty="0"/>
           </a:p>
@@ -2419,7 +2419,7 @@
                 <a:ea typeface="Arial" pitchFamily="34" charset="-122"/>
                 <a:cs typeface="Arial" pitchFamily="34" charset="-120"/>
               </a:rPr>
-              <a:t>Queue → review/verify → prioritize → assign → close.</a:t>
+              <a:t>Queue → validate → prioritize → assign → close. Teams, users, analytics, exports.</a:t>
             </a:r>
             <a:endParaRPr lang="en-US" sz="1900" dirty="0"/>
           </a:p>
@@ -2483,7 +2483,7 @@
                 <a:ea typeface="Arial" pitchFamily="34" charset="-122"/>
                 <a:cs typeface="Arial" pitchFamily="34" charset="-120"/>
               </a:rPr>
-              <a:t>DMO</a:t>
+              <a:t>Rescuer</a:t>
             </a:r>
             <a:endParaRPr lang="en-US" sz="2500" dirty="0"/>
           </a:p>
@@ -2522,7 +2522,7 @@
                 <a:ea typeface="Arial" pitchFamily="34" charset="-122"/>
                 <a:cs typeface="Arial" pitchFamily="34" charset="-120"/>
               </a:rPr>
-              <a:t>Monitor incidents and trends; inspect analytics and exports.</a:t>
+              <a:t>Your team’s assignments and closed reports. Post progress as on the phone.</a:t>
             </a:r>
             <a:endParaRPr lang="en-US" sz="1900" dirty="0"/>
           </a:p>
@@ -2586,7 +2586,7 @@
                 <a:ea typeface="Arial" pitchFamily="34" charset="-122"/>
                 <a:cs typeface="Arial" pitchFamily="34" charset="-120"/>
               </a:rPr>
-              <a:t>Admin</a:t>
+              <a:t>Dispatcher and DMO</a:t>
             </a:r>
             <a:endParaRPr lang="en-US" sz="2500" dirty="0"/>
           </a:p>
@@ -2625,7 +2625,7 @@
                 <a:ea typeface="Arial" pitchFamily="34" charset="-122"/>
                 <a:cs typeface="Arial" pitchFamily="34" charset="-120"/>
               </a:rPr>
-              <a:t>Manage accounts and teams, and use granted staff routes.</a:t>
+              <a:t>Retired. Sign-in is refused; the administrator does this work.</a:t>
             </a:r>
             <a:endParaRPr lang="en-US" sz="1900" dirty="0"/>
           </a:p>
@@ -4383,7 +4383,7 @@
                           <a:ea typeface="Arial" pitchFamily="34" charset="-122"/>
                           <a:cs typeface="Arial" pitchFamily="34" charset="-120"/>
                         </a:rPr>
-                        <a:t>Flutter or web /my</a:t>
+                        <a:t>Phone app only</a:t>
                       </a:r>
                       <a:endParaRPr lang="en-US" sz="1700" dirty="0">
                         <a:latin typeface="Arial" charset="0"/>
@@ -4521,7 +4521,7 @@
                           <a:ea typeface="Arial" pitchFamily="34" charset="-122"/>
                           <a:cs typeface="Arial" pitchFamily="34" charset="-120"/>
                         </a:rPr>
-                        <a:t>Responder</a:t>
+                        <a:t>Rescuer (responder)</a:t>
                       </a:r>
                       <a:endParaRPr lang="en-US" sz="1700" dirty="0">
                         <a:latin typeface="Arial" charset="0"/>
@@ -4589,7 +4589,7 @@
                           <a:ea typeface="Arial" pitchFamily="34" charset="-122"/>
                           <a:cs typeface="Arial" pitchFamily="34" charset="-120"/>
                         </a:rPr>
-                        <a:t>Flutter or web /assignments</a:t>
+                        <a:t>Phone app or web /assignments</a:t>
                       </a:r>
                       <a:endParaRPr lang="en-US" sz="1700" dirty="0">
                         <a:latin typeface="Arial" charset="0"/>
@@ -4657,7 +4657,7 @@
                           <a:ea typeface="Arial" pitchFamily="34" charset="-122"/>
                           <a:cs typeface="Arial" pitchFamily="34" charset="-120"/>
                         </a:rPr>
-                        <a:t>Current-team assignments and progress</a:t>
+                        <a:t>Current-team assignments, progress and closed reports</a:t>
                       </a:r>
                       <a:endParaRPr lang="en-US" sz="1700" dirty="0">
                         <a:latin typeface="Arial" charset="0"/>
@@ -4727,7 +4727,7 @@
                           <a:ea typeface="Arial" pitchFamily="34" charset="-122"/>
                           <a:cs typeface="Arial" pitchFamily="34" charset="-120"/>
                         </a:rPr>
-                        <a:t>Dispatcher</a:t>
+                        <a:t>Administrator</a:t>
                       </a:r>
                       <a:endParaRPr lang="en-US" sz="1700" dirty="0">
                         <a:latin typeface="Arial" charset="0"/>
@@ -4795,7 +4795,7 @@
                           <a:ea typeface="Arial" pitchFamily="34" charset="-122"/>
                           <a:cs typeface="Arial" pitchFamily="34" charset="-120"/>
                         </a:rPr>
-                        <a:t>Web /dashboard</a:t>
+                        <a:t>Web only: /dashboard, /admin</a:t>
                       </a:r>
                       <a:endParaRPr lang="en-US" sz="1700" dirty="0">
                         <a:latin typeface="Arial" charset="0"/>
@@ -4863,7 +4863,7 @@
                           <a:ea typeface="Arial" pitchFamily="34" charset="-122"/>
                           <a:cs typeface="Arial" pitchFamily="34" charset="-120"/>
                         </a:rPr>
-                        <a:t>Review, prioritize and coordinate</a:t>
+                        <a:t>Verify, assign, close, manage teams and users, analytics and exports</a:t>
                       </a:r>
                       <a:endParaRPr lang="en-US" sz="1700" dirty="0">
                         <a:latin typeface="Arial" charset="0"/>
@@ -4933,7 +4933,7 @@
                           <a:ea typeface="Arial" pitchFamily="34" charset="-122"/>
                           <a:cs typeface="Arial" pitchFamily="34" charset="-120"/>
                         </a:rPr>
-                        <a:t>DMO</a:t>
+                        <a:t>Dispatcher and DMO</a:t>
                       </a:r>
                       <a:endParaRPr lang="en-US" sz="1700" dirty="0">
                         <a:latin typeface="Arial" charset="0"/>
@@ -5001,7 +5001,7 @@
                           <a:ea typeface="Arial" pitchFamily="34" charset="-122"/>
                           <a:cs typeface="Arial" pitchFamily="34" charset="-120"/>
                         </a:rPr>
-                        <a:t>Web /monitor</a:t>
+                        <a:t>No access (retired)</a:t>
                       </a:r>
                       <a:endParaRPr lang="en-US" sz="1700" dirty="0">
                         <a:latin typeface="Arial" charset="0"/>
@@ -5069,213 +5069,7 @@
                           <a:ea typeface="Arial" pitchFamily="34" charset="-122"/>
                           <a:cs typeface="Arial" pitchFamily="34" charset="-120"/>
                         </a:rPr>
-                        <a:t>Read-only monitoring and analytics</a:t>
-                      </a:r>
-                      <a:endParaRPr lang="en-US" sz="1700" dirty="0">
-                        <a:latin typeface="Arial" charset="0"/>
-                        <a:ea typeface="Arial" charset="0"/>
-                        <a:cs typeface="Arial" charset="0"/>
-                      </a:endParaRPr>
-                    </a:p>
-                  </a:txBody>
-                  <a:tcPr marL="118872" marR="118872" marT="118872" marB="118872">
-                    <a:lnL w="6350" cap="flat" cmpd="sng" algn="ctr">
-                      <a:solidFill>
-                        <a:srgbClr val="E5E3ED"/>
-                      </a:solidFill>
-                      <a:prstDash val="solid"/>
-                      <a:round/>
-                      <a:headEnd type="none" w="med" len="med"/>
-                      <a:tailEnd type="none" w="med" len="med"/>
-                    </a:lnL>
-                    <a:lnR w="6350" cap="flat" cmpd="sng" algn="ctr">
-                      <a:solidFill>
-                        <a:srgbClr val="E5E3ED"/>
-                      </a:solidFill>
-                      <a:prstDash val="solid"/>
-                      <a:round/>
-                      <a:headEnd type="none" w="med" len="med"/>
-                      <a:tailEnd type="none" w="med" len="med"/>
-                    </a:lnR>
-                    <a:lnT w="6350" cap="flat" cmpd="sng" algn="ctr">
-                      <a:solidFill>
-                        <a:srgbClr val="E5E3ED"/>
-                      </a:solidFill>
-                      <a:prstDash val="solid"/>
-                      <a:round/>
-                      <a:headEnd type="none" w="med" len="med"/>
-                      <a:tailEnd type="none" w="med" len="med"/>
-                    </a:lnT>
-                    <a:lnB w="6350" cap="flat" cmpd="sng" algn="ctr">
-                      <a:solidFill>
-                        <a:srgbClr val="E5E3ED"/>
-                      </a:solidFill>
-                      <a:prstDash val="solid"/>
-                      <a:round/>
-                      <a:headEnd type="none" w="med" len="med"/>
-                      <a:tailEnd type="none" w="med" len="med"/>
-                    </a:lnB>
-                    <a:solidFill>
-                      <a:srgbClr val="FFFFFF"/>
-                    </a:solidFill>
-                  </a:tcPr>
-                </a:tc>
-              </a:tr>
-              <a:tr h="502920">
-                <a:tc>
-                  <a:txBody>
-                    <a:bodyPr/>
-                    <a:lstStyle/>
-                    <a:p>
-                      <a:pPr indent="0" marL="0">
-                        <a:buNone/>
-                      </a:pPr>
-                      <a:r>
-                        <a:rPr lang="en-US" sz="1700" dirty="0">
-                          <a:solidFill>
-                            <a:srgbClr val="211D35"/>
-                          </a:solidFill>
-                          <a:latin typeface="Arial" pitchFamily="34" charset="0"/>
-                          <a:ea typeface="Arial" pitchFamily="34" charset="-122"/>
-                          <a:cs typeface="Arial" pitchFamily="34" charset="-120"/>
-                        </a:rPr>
-                        <a:t>Admin</a:t>
-                      </a:r>
-                      <a:endParaRPr lang="en-US" sz="1700" dirty="0">
-                        <a:latin typeface="Arial" charset="0"/>
-                        <a:ea typeface="Arial" charset="0"/>
-                        <a:cs typeface="Arial" charset="0"/>
-                      </a:endParaRPr>
-                    </a:p>
-                  </a:txBody>
-                  <a:tcPr marL="118872" marR="118872" marT="118872" marB="118872">
-                    <a:lnL w="6350" cap="flat" cmpd="sng" algn="ctr">
-                      <a:solidFill>
-                        <a:srgbClr val="E5E3ED"/>
-                      </a:solidFill>
-                      <a:prstDash val="solid"/>
-                      <a:round/>
-                      <a:headEnd type="none" w="med" len="med"/>
-                      <a:tailEnd type="none" w="med" len="med"/>
-                    </a:lnL>
-                    <a:lnR w="6350" cap="flat" cmpd="sng" algn="ctr">
-                      <a:solidFill>
-                        <a:srgbClr val="E5E3ED"/>
-                      </a:solidFill>
-                      <a:prstDash val="solid"/>
-                      <a:round/>
-                      <a:headEnd type="none" w="med" len="med"/>
-                      <a:tailEnd type="none" w="med" len="med"/>
-                    </a:lnR>
-                    <a:lnT w="6350" cap="flat" cmpd="sng" algn="ctr">
-                      <a:solidFill>
-                        <a:srgbClr val="E5E3ED"/>
-                      </a:solidFill>
-                      <a:prstDash val="solid"/>
-                      <a:round/>
-                      <a:headEnd type="none" w="med" len="med"/>
-                      <a:tailEnd type="none" w="med" len="med"/>
-                    </a:lnT>
-                    <a:lnB w="6350" cap="flat" cmpd="sng" algn="ctr">
-                      <a:solidFill>
-                        <a:srgbClr val="E5E3ED"/>
-                      </a:solidFill>
-                      <a:prstDash val="solid"/>
-                      <a:round/>
-                      <a:headEnd type="none" w="med" len="med"/>
-                      <a:tailEnd type="none" w="med" len="med"/>
-                    </a:lnB>
-                    <a:solidFill>
-                      <a:srgbClr val="FFFFFF"/>
-                    </a:solidFill>
-                  </a:tcPr>
-                </a:tc>
-                <a:tc>
-                  <a:txBody>
-                    <a:bodyPr/>
-                    <a:lstStyle/>
-                    <a:p>
-                      <a:pPr indent="0" marL="0">
-                        <a:buNone/>
-                      </a:pPr>
-                      <a:r>
-                        <a:rPr lang="en-US" sz="1700" dirty="0">
-                          <a:solidFill>
-                            <a:srgbClr val="211D35"/>
-                          </a:solidFill>
-                          <a:latin typeface="Arial" pitchFamily="34" charset="0"/>
-                          <a:ea typeface="Arial" pitchFamily="34" charset="-122"/>
-                          <a:cs typeface="Arial" pitchFamily="34" charset="-120"/>
-                        </a:rPr>
-                        <a:t>Web /admin</a:t>
-                      </a:r>
-                      <a:endParaRPr lang="en-US" sz="1700" dirty="0">
-                        <a:latin typeface="Arial" charset="0"/>
-                        <a:ea typeface="Arial" charset="0"/>
-                        <a:cs typeface="Arial" charset="0"/>
-                      </a:endParaRPr>
-                    </a:p>
-                  </a:txBody>
-                  <a:tcPr marL="118872" marR="118872" marT="118872" marB="118872">
-                    <a:lnL w="6350" cap="flat" cmpd="sng" algn="ctr">
-                      <a:solidFill>
-                        <a:srgbClr val="E5E3ED"/>
-                      </a:solidFill>
-                      <a:prstDash val="solid"/>
-                      <a:round/>
-                      <a:headEnd type="none" w="med" len="med"/>
-                      <a:tailEnd type="none" w="med" len="med"/>
-                    </a:lnL>
-                    <a:lnR w="6350" cap="flat" cmpd="sng" algn="ctr">
-                      <a:solidFill>
-                        <a:srgbClr val="E5E3ED"/>
-                      </a:solidFill>
-                      <a:prstDash val="solid"/>
-                      <a:round/>
-                      <a:headEnd type="none" w="med" len="med"/>
-                      <a:tailEnd type="none" w="med" len="med"/>
-                    </a:lnR>
-                    <a:lnT w="6350" cap="flat" cmpd="sng" algn="ctr">
-                      <a:solidFill>
-                        <a:srgbClr val="E5E3ED"/>
-                      </a:solidFill>
-                      <a:prstDash val="solid"/>
-                      <a:round/>
-                      <a:headEnd type="none" w="med" len="med"/>
-                      <a:tailEnd type="none" w="med" len="med"/>
-                    </a:lnT>
-                    <a:lnB w="6350" cap="flat" cmpd="sng" algn="ctr">
-                      <a:solidFill>
-                        <a:srgbClr val="E5E3ED"/>
-                      </a:solidFill>
-                      <a:prstDash val="solid"/>
-                      <a:round/>
-                      <a:headEnd type="none" w="med" len="med"/>
-                      <a:tailEnd type="none" w="med" len="med"/>
-                    </a:lnB>
-                    <a:solidFill>
-                      <a:srgbClr val="FFFFFF"/>
-                    </a:solidFill>
-                  </a:tcPr>
-                </a:tc>
-                <a:tc>
-                  <a:txBody>
-                    <a:bodyPr/>
-                    <a:lstStyle/>
-                    <a:p>
-                      <a:pPr indent="0" marL="0">
-                        <a:buNone/>
-                      </a:pPr>
-                      <a:r>
-                        <a:rPr lang="en-US" sz="1700" dirty="0">
-                          <a:solidFill>
-                            <a:srgbClr val="211D35"/>
-                          </a:solidFill>
-                          <a:latin typeface="Arial" pitchFamily="34" charset="0"/>
-                          <a:ea typeface="Arial" pitchFamily="34" charset="-122"/>
-                          <a:cs typeface="Arial" pitchFamily="34" charset="-120"/>
-                        </a:rPr>
-                        <a:t>Account, team and staff administration</a:t>
+                        <a:t>Accounts and history kept; the administrator does their work</a:t>
                       </a:r>
                       <a:endParaRPr lang="en-US" sz="1700" dirty="0">
                         <a:latin typeface="Arial" charset="0"/>
@@ -5591,7 +5385,7 @@
                 <a:ea typeface="Arial" pitchFamily="34" charset="-122"/>
                 <a:cs typeface="Arial" pitchFamily="34" charset="-120"/>
               </a:rPr>
-              <a:t>Create a resident account for personal reporting.</a:t>
+              <a:t>Create a resident account in the phone app.</a:t>
             </a:r>
             <a:endParaRPr lang="en-US" sz="1900" dirty="0"/>
           </a:p>
@@ -5669,7 +5463,7 @@
                 <a:ea typeface="Arial" pitchFamily="34" charset="-122"/>
                 <a:cs typeface="Arial" pitchFamily="34" charset="-120"/>
               </a:rPr>
-              <a:t>Use shared sign-in for residents and assigned responders.</a:t>
+              <a:t>Residents use the phone app only.</a:t>
             </a:r>
             <a:endParaRPr lang="en-US" sz="1900" dirty="0"/>
           </a:p>
@@ -5747,7 +5541,7 @@
                 <a:ea typeface="Arial" pitchFamily="34" charset="-122"/>
                 <a:cs typeface="Arial" pitchFamily="34" charset="-120"/>
               </a:rPr>
-              <a:t>Staff administration stays in the web workspace.</a:t>
+              <a:t>Rescuers can sign in on the phone or the website.</a:t>
             </a:r>
             <a:endParaRPr lang="en-US" sz="1900" dirty="0"/>
           </a:p>
@@ -5825,7 +5619,7 @@
                 <a:ea typeface="Arial" pitchFamily="34" charset="-122"/>
                 <a:cs typeface="Arial" pitchFamily="34" charset="-120"/>
               </a:rPr>
-              <a:t>Read the safety notice before reporting.</a:t>
+              <a:t>Administrators use the website only.</a:t>
             </a:r>
             <a:endParaRPr lang="en-US" sz="1900" dirty="0"/>
           </a:p>
@@ -5833,7 +5627,7 @@
       </p:sp>
       <p:pic>
         <p:nvPicPr>
-          <p:cNvPr id="14" name="Image 0" descr="/private/tmp/rescue-release-integration-2026-10-18/docs/user-guide/images/welcome-390-r2.png">    </p:cNvPr>
+          <p:cNvPr id="14" name="Image 0" descr="/Users/rien/Documents/FINAL_PROJECT-rescuer-web/docs/user-guide/images/welcome-390-r2.png">    </p:cNvPr>
           <p:cNvPicPr>
             <a:picLocks noChangeAspect="1"/>
           </p:cNvPicPr>
@@ -6357,7 +6151,7 @@
       </p:sp>
       <p:pic>
         <p:nvPicPr>
-          <p:cNvPr id="14" name="Image 0" descr="/private/tmp/rescue-release-integration-2026-10-18/docs/user-guide/images/location-390.png">    </p:cNvPr>
+          <p:cNvPr id="14" name="Image 0" descr="/Users/rien/Documents/FINAL_PROJECT-rescuer-web/docs/user-guide/images/location-390.png">    </p:cNvPr>
           <p:cNvPicPr>
             <a:picLocks noChangeAspect="1"/>
           </p:cNvPicPr>
@@ -7378,7 +7172,7 @@
       </p:sp>
       <p:pic>
         <p:nvPicPr>
-          <p:cNvPr id="14" name="Image 0" descr="/private/tmp/rescue-release-integration-2026-10-18/docs/user-guide/images/notifications-390.png">    </p:cNvPr>
+          <p:cNvPr id="14" name="Image 0" descr="/Users/rien/Documents/FINAL_PROJECT-rescuer-web/docs/user-guide/images/notifications-390.png">    </p:cNvPr>
           <p:cNvPicPr>
             <a:picLocks noChangeAspect="1"/>
           </p:cNvPicPr>
@@ -7902,7 +7696,7 @@
       </p:sp>
       <p:pic>
         <p:nvPicPr>
-          <p:cNvPr id="14" name="Image 0" descr="/private/tmp/rescue-release-integration-2026-10-18/docs/user-guide/images/assigned-390.png">    </p:cNvPr>
+          <p:cNvPr id="14" name="Image 0" descr="/Users/rien/Documents/FINAL_PROJECT-rescuer-web/docs/user-guide/images/assigned-390.png">    </p:cNvPr>
           <p:cNvPicPr>
             <a:picLocks noChangeAspect="1"/>
           </p:cNvPicPr>
@@ -8426,7 +8220,7 @@
       </p:sp>
       <p:pic>
         <p:nvPicPr>
-          <p:cNvPr id="14" name="Image 0" descr="/private/tmp/rescue-release-integration-2026-10-18/docs/user-guide/images/update-390.png">    </p:cNvPr>
+          <p:cNvPr id="14" name="Image 0" descr="/Users/rien/Documents/FINAL_PROJECT-rescuer-web/docs/user-guide/images/update-390.png">    </p:cNvPr>
           <p:cNvPicPr>
             <a:picLocks noChangeAspect="1"/>
           </p:cNvPicPr>
@@ -8950,7 +8744,7 @@
       </p:sp>
       <p:pic>
         <p:nvPicPr>
-          <p:cNvPr id="14" name="Image 0" descr="/private/tmp/rescue-release-integration-2026-10-18/docs/user-guide/images/history-390.png">    </p:cNvPr>
+          <p:cNvPr id="14" name="Image 0" descr="/Users/rien/Documents/FINAL_PROJECT-rescuer-web/docs/user-guide/images/history-390.png">    </p:cNvPr>
           <p:cNvPicPr>
             <a:picLocks noChangeAspect="1"/>
           </p:cNvPicPr>

</xml_diff>